<commit_message>
docs: FR-29..FR-32, BR-21/22, CR-22..CR-26 across SRS, traceability, report, diagrams, slides, demo script
Co-Authored-By: Claude Opus 5.5 <noreply@anthropic.com>
</commit_message>
<xml_diff>
--- a/docs/presentation/CivicLink_Presentation.pptx
+++ b/docs/presentation/CivicLink_Presentation.pptx
@@ -3497,7 +3497,7 @@
                   <a:srgbClr val="1E293B"/>
                 </a:solidFill>
               </a:rPr>
-              <a:t>Four roles, one lifecycle: 24 of 28 requirements delivered</a:t>
+              <a:t>Four roles, one lifecycle: 28 of 32 requirements delivered</a:t>
             </a:r>
           </a:p>
         </p:txBody>
@@ -3646,6 +3646,29 @@
                 </a:solidFill>
               </a:rPr>
               <a:t> staff accounts, roles, departments, SLA targets, system log</a:t>
+            </a:r>
+          </a:p>
+          <a:p>
+            <a:pPr>
+              <a:spcAft>
+                <a:spcPts val="1000"/>
+              </a:spcAft>
+            </a:pPr>
+            <a:r>
+              <a:rPr sz="1700" b="1">
+                <a:solidFill>
+                  <a:srgbClr val="1E293B"/>
+                </a:solidFill>
+              </a:rPr>
+              <a:t>Accounts</a:t>
+            </a:r>
+            <a:r>
+              <a:rPr sz="1700">
+                <a:solidFill>
+                  <a:srgbClr val="475569"/>
+                </a:solidFill>
+              </a:rPr>
+              <a:t> Google sign-in, password reset, profile, POPIA self-deletion with anonymised records</a:t>
             </a:r>
           </a:p>
           <a:p>
@@ -4370,7 +4393,7 @@
                   <a:srgbClr val="1E293B"/>
                 </a:solidFill>
               </a:rPr>
-              <a:t>119 automated tests, all green in CI</a:t>
+              <a:t>132 automated tests, all green in CI</a:t>
             </a:r>
           </a:p>
         </p:txBody>
@@ -4441,7 +4464,7 @@
                   <a:srgbClr val="1E293B"/>
                 </a:solidFill>
               </a:rPr>
-              <a:t>Unit (28)</a:t>
+              <a:t>Unit (29)</a:t>
             </a:r>
             <a:r>
               <a:rPr sz="1600">
@@ -4487,7 +4510,7 @@
                   <a:srgbClr val="1E293B"/>
                 </a:solidFill>
               </a:rPr>
-              <a:t>API integration (62)</a:t>
+              <a:t>API integration (70)</a:t>
             </a:r>
             <a:r>
               <a:rPr sz="1600">
@@ -4510,7 +4533,7 @@
                   <a:srgbClr val="1E293B"/>
                 </a:solidFill>
               </a:rPr>
-              <a:t>End-to-end (9)</a:t>
+              <a:t>End-to-end (13)</a:t>
             </a:r>
             <a:r>
               <a:rPr sz="1600">
@@ -4518,7 +4541,7 @@
                   <a:srgbClr val="475569"/>
                 </a:solidFill>
               </a:rPr>
-              <a:t> full lifecycle across 3 browsers, duplicates, alerts, access denied; Chrome and Firefox; 360 px</a:t>
+              <a:t> full lifecycle across 3 browsers, duplicates, alerts, access denied, Google sign-in, POPIA deletion; Chrome and Firefox; 360 px</a:t>
             </a:r>
           </a:p>
           <a:p>

</xml_diff>

<commit_message>
docs: ADR-0006 free-tier deployment; Storage removed from SRS, traceability, report, diagrams; deploy runbook; prod seed mode
- Report D3 is now the free-tier decision (Spark + Vercel Node API + photos in Firestore)
- Architecture and deployment diagrams show both runtime configurations
- docs/deploy.md: Firebase console, rules, Vercel env, GitHub schedule, seeding, smoke test
- seed:prod refuses non-empty projects; SEED_PASSWORD keeps the public demo password private
- CR-27, CR-28

Co-Authored-By: Claude Opus 5.5 <noreply@anthropic.com>
</commit_message>
<xml_diff>
--- a/docs/presentation/CivicLink_Presentation.pptx
+++ b/docs/presentation/CivicLink_Presentation.pptx
@@ -3897,7 +3897,7 @@
         <p:spPr>
           <a:xfrm>
             <a:off x="548640" y="1463040"/>
-            <a:ext cx="7186164" cy="4754880"/>
+            <a:ext cx="5002800" cy="4754880"/>
           </a:xfrm>
           <a:prstGeom prst="rect">
             <a:avLst/>
@@ -3960,7 +3960,7 @@
                   <a:srgbClr val="1E293B"/>
                 </a:solidFill>
               </a:rPr>
-              <a:t>Callable Cloud Functions</a:t>
+              <a:t>Node command API</a:t>
             </a:r>
             <a:r>
               <a:rPr sz="1500">
@@ -3968,7 +3968,7 @@
                   <a:srgbClr val="475569"/>
                 </a:solidFill>
               </a:rPr>
-              <a:t> authenticate, check the role, validate (shared Zod schemas), run transactions</a:t>
+              <a:t> one registry of 26 commands: auth, roles, Zod validation, transactions; served by Vercel (deployed) or Cloud Functions (local)</a:t>
             </a:r>
           </a:p>
           <a:p>
@@ -4006,7 +4006,7 @@
                   <a:srgbClr val="1E293B"/>
                 </a:solidFill>
               </a:rPr>
-              <a:t>Firebase Emulator Suite</a:t>
+              <a:t>Free tier</a:t>
             </a:r>
             <a:r>
               <a:rPr sz="1500">
@@ -4014,7 +4014,7 @@
                   <a:srgbClr val="475569"/>
                 </a:solidFill>
               </a:rPr>
-              <a:t> assessed runtime: reproducible with no cloud account</a:t>
+              <a:t> Vercel + Firebase Spark; photos stored in Firestore; emulator for offline demo and tests</a:t>
             </a:r>
           </a:p>
         </p:txBody>
@@ -4235,7 +4235,7 @@
                   <a:srgbClr val="1E293B"/>
                 </a:solidFill>
               </a:rPr>
-              <a:t>D3: The emulator is the assessed runtime</a:t>
+              <a:t>D3: Free-tier deployment without Cloud Functions</a:t>
             </a:r>
             <a:r>
               <a:rPr sz="1800">
@@ -4243,7 +4243,7 @@
                   <a:srgbClr val="475569"/>
                 </a:solidFill>
               </a:rPr>
-              <a:t> Zero cost, no network risk in the demo, identical to CI. Trade-off: schedules are triggered by an admin action locally, and push notifications are deferred.</a:t>
+              <a:t> Firebase Spark + a Node API on Vercel; photos compressed to ≤ 700 KB and stored in Firestore with real-type checks. One command registry, two adapters, and CI runs every E2E test through both.</a:t>
             </a:r>
           </a:p>
           <a:p>
@@ -4393,7 +4393,7 @@
                   <a:srgbClr val="1E293B"/>
                 </a:solidFill>
               </a:rPr>
-              <a:t>132 automated tests, all green in CI</a:t>
+              <a:t>136 automated tests, all green in CI</a:t>
             </a:r>
           </a:p>
         </p:txBody>
@@ -4464,7 +4464,7 @@
                   <a:srgbClr val="1E293B"/>
                 </a:solidFill>
               </a:rPr>
-              <a:t>Unit (29)</a:t>
+              <a:t>Unit (30)</a:t>
             </a:r>
             <a:r>
               <a:rPr sz="1600">
@@ -4510,7 +4510,7 @@
                   <a:srgbClr val="1E293B"/>
                 </a:solidFill>
               </a:rPr>
-              <a:t>API integration (70)</a:t>
+              <a:t>API integration (74)</a:t>
             </a:r>
             <a:r>
               <a:rPr sz="1600">

</xml_diff>

<commit_message>
docs(presentation): slides and drill sheet for push, Me too and offline; counts 31/34, 143 tests
Co-Authored-By: Claude Opus 5.5 <noreply@anthropic.com>
</commit_message>
<xml_diff>
--- a/docs/presentation/CivicLink_Presentation.pptx
+++ b/docs/presentation/CivicLink_Presentation.pptx
@@ -3497,7 +3497,7 @@
                   <a:srgbClr val="1E293B"/>
                 </a:solidFill>
               </a:rPr>
-              <a:t>Four roles, one lifecycle: 28 of 32 requirements delivered</a:t>
+              <a:t>Four roles, one lifecycle: 31 of 34 requirements delivered</a:t>
             </a:r>
           </a:p>
         </p:txBody>
@@ -3669,6 +3669,29 @@
                 </a:solidFill>
               </a:rPr>
               <a:t> Google sign-in, password reset, profile, POPIA self-deletion with anonymised records</a:t>
+            </a:r>
+          </a:p>
+          <a:p>
+            <a:pPr>
+              <a:spcAft>
+                <a:spcPts val="1000"/>
+              </a:spcAft>
+            </a:pPr>
+            <a:r>
+              <a:rPr sz="1700" b="1">
+                <a:solidFill>
+                  <a:srgbClr val="1E293B"/>
+                </a:solidFill>
+              </a:rPr>
+              <a:t>Reach</a:t>
+            </a:r>
+            <a:r>
+              <a:rPr sz="1700">
+                <a:solidFill>
+                  <a:srgbClr val="475569"/>
+                </a:solidFill>
+              </a:rPr>
+              <a:t> web push to phones, "Me too" on the map, installable app that opens offline</a:t>
             </a:r>
           </a:p>
           <a:p>
@@ -3897,7 +3920,7 @@
         <p:spPr>
           <a:xfrm>
             <a:off x="548640" y="1463040"/>
-            <a:ext cx="5002800" cy="4754880"/>
+            <a:ext cx="5294058" cy="4754880"/>
           </a:xfrm>
           <a:prstGeom prst="rect">
             <a:avLst/>
@@ -4393,7 +4416,7 @@
                   <a:srgbClr val="1E293B"/>
                 </a:solidFill>
               </a:rPr>
-              <a:t>136 automated tests, all green in CI</a:t>
+              <a:t>143 automated tests, all green in CI</a:t>
             </a:r>
           </a:p>
         </p:txBody>
@@ -4510,7 +4533,7 @@
                   <a:srgbClr val="1E293B"/>
                 </a:solidFill>
               </a:rPr>
-              <a:t>API integration (74)</a:t>
+              <a:t>API integration (79)</a:t>
             </a:r>
             <a:r>
               <a:rPr sz="1600">
@@ -4518,7 +4541,7 @@
                   <a:srgbClr val="475569"/>
                 </a:solidFill>
               </a:rPr>
-              <a:t> validation, authorisation, wrong-state and concurrency for every command</a:t>
+              <a:t> validation, authorisation, wrong-state and concurrency for every command; push with a fake sender</a:t>
             </a:r>
           </a:p>
           <a:p>
@@ -4533,7 +4556,7 @@
                   <a:srgbClr val="1E293B"/>
                 </a:solidFill>
               </a:rPr>
-              <a:t>End-to-end (13)</a:t>
+              <a:t>End-to-end + PWA (15)</a:t>
             </a:r>
             <a:r>
               <a:rPr sz="1600">
@@ -4541,7 +4564,7 @@
                   <a:srgbClr val="475569"/>
                 </a:solidFill>
               </a:rPr>
-              <a:t> full lifecycle across 3 browsers, duplicates, alerts, access denied, Google sign-in, POPIA deletion; Chrome and Firefox; 360 px</a:t>
+              <a:t> full lifecycle across 3 browsers, duplicates, Me too, alerts, access denied, Google sign-in, POPIA deletion, offline install; Chrome and Firefox</a:t>
             </a:r>
           </a:p>
           <a:p>

</xml_diff>

<commit_message>
docs: requirements, design, diagrams, evidence and slides for release 1.1 features
Co-Authored-By: Claude Opus 5.5 <noreply@anthropic.com>
</commit_message>
<xml_diff>
--- a/docs/presentation/CivicLink_Presentation.pptx
+++ b/docs/presentation/CivicLink_Presentation.pptx
@@ -3497,7 +3497,7 @@
                   <a:srgbClr val="1E293B"/>
                 </a:solidFill>
               </a:rPr>
-              <a:t>Four roles, one lifecycle: 31 of 34 requirements delivered</a:t>
+              <a:t>Four roles, one lifecycle: all 37 requirements delivered</a:t>
             </a:r>
           </a:p>
         </p:txBody>
@@ -3576,7 +3576,7 @@
                   <a:srgbClr val="475569"/>
                 </a:solidFill>
               </a:rPr>
-              <a:t> report in 3 steps (map pin, photos, severity), get a reference, follow it live, confirm or reopen</a:t>
+              <a:t> report in 3 steps (map pin, photos, severity), even offline; get a reference, follow it live, confirm with a rating or reopen</a:t>
             </a:r>
           </a:p>
           <a:p>
@@ -3599,7 +3599,7 @@
                   <a:srgbClr val="475569"/>
                 </a:solidFill>
               </a:rPr>
-              <a:t> department queue, triage, assign, escalate, suburb alerts, live analytics</a:t>
+              <a:t> department queue, triage, assign (one or many), escalate, suburb alerts now or scheduled, live analytics</a:t>
             </a:r>
           </a:p>
           <a:p>
@@ -3691,7 +3691,7 @@
                   <a:srgbClr val="475569"/>
                 </a:solidFill>
               </a:rPr>
-              <a:t> web push to phones, "Me too" on the map, installable app that opens offline</a:t>
+              <a:t> web push, SMS for emergencies, "Me too" on the map, installable app that saves reports offline</a:t>
             </a:r>
           </a:p>
           <a:p>
@@ -3706,7 +3706,7 @@
                   <a:srgbClr val="1E293B"/>
                 </a:solidFill>
               </a:rPr>
-              <a:t>Deferred on purpose</a:t>
+              <a:t>Transparency</a:t>
             </a:r>
             <a:r>
               <a:rPr sz="1700">
@@ -3714,7 +3714,7 @@
                   <a:srgbClr val="475569"/>
                 </a:solidFill>
               </a:rPr>
-              <a:t> push and SMS, offline drafts, scheduled alerts: not verifiable in the assessment environment</a:t>
+              <a:t> a public page with time-to-fix, SLA compliance and satisfaction, served from the CDN</a:t>
             </a:r>
           </a:p>
         </p:txBody>
@@ -3920,7 +3920,7 @@
         <p:spPr>
           <a:xfrm>
             <a:off x="548640" y="1463040"/>
-            <a:ext cx="5294058" cy="4754880"/>
+            <a:ext cx="5903024" cy="4754880"/>
           </a:xfrm>
           <a:prstGeom prst="rect">
             <a:avLst/>
@@ -3991,7 +3991,7 @@
                   <a:srgbClr val="475569"/>
                 </a:solidFill>
               </a:rPr>
-              <a:t> one registry of 26 commands: auth, roles, Zod validation, transactions; served by Vercel (deployed) or Cloud Functions (local)</a:t>
+              <a:t> one registry of 31 commands: auth, roles, Zod validation, transactions; served by Vercel (deployed) or Cloud Functions (local)</a:t>
             </a:r>
           </a:p>
           <a:p>
@@ -4164,7 +4164,7 @@
                   <a:srgbClr val="1E293B"/>
                 </a:solidFill>
               </a:rPr>
-              <a:t>Two decisions that shaped the system</a:t>
+              <a:t>Decisions that shaped the system</a:t>
             </a:r>
           </a:p>
         </p:txBody>
@@ -4281,6 +4281,29 @@
                   <a:srgbClr val="1E293B"/>
                 </a:solidFill>
               </a:rPr>
+              <a:t>D5: Offline reports through an outbox and idempotent commands</a:t>
+            </a:r>
+            <a:r>
+              <a:rPr sz="1800">
+                <a:solidFill>
+                  <a:srgbClr val="475569"/>
+                </a:solidFill>
+              </a:rPr>
+              <a:t> Saved on the phone (IndexedDB) and sent on reconnect with a device-chosen id, so a resend is stored once. Works in every browser, unlike Background Sync.</a:t>
+            </a:r>
+          </a:p>
+          <a:p>
+            <a:pPr>
+              <a:spcAft>
+                <a:spcPts val="1000"/>
+              </a:spcAft>
+            </a:pPr>
+            <a:r>
+              <a:rPr sz="1800" b="1">
+                <a:solidFill>
+                  <a:srgbClr val="1E293B"/>
+                </a:solidFill>
+              </a:rPr>
               <a:t>Also:</a:t>
             </a:r>
             <a:r>
@@ -4289,7 +4312,7 @@
                   <a:srgbClr val="475569"/>
                 </a:solidFill>
               </a:rPr>
-              <a:t> Leaflet + OpenStreetMap instead of Google Maps (no billing); React SPA instead of Next.js (no server rendering needed).</a:t>
+              <a:t> public figures from the CDN cache (D6); enforced CSP + HSTS; Leaflet + OpenStreetMap instead of Google Maps; React SPA instead of Next.js.</a:t>
             </a:r>
           </a:p>
         </p:txBody>
@@ -4416,7 +4439,7 @@
                   <a:srgbClr val="1E293B"/>
                 </a:solidFill>
               </a:rPr>
-              <a:t>143 automated tests, all green in CI</a:t>
+              <a:t>173 automated tests, all green</a:t>
             </a:r>
           </a:p>
         </p:txBody>
@@ -4487,7 +4510,7 @@
                   <a:srgbClr val="1E293B"/>
                 </a:solidFill>
               </a:rPr>
-              <a:t>Unit (30)</a:t>
+              <a:t>Unit (40)</a:t>
             </a:r>
             <a:r>
               <a:rPr sz="1600">
@@ -4495,7 +4518,7 @@
                   <a:srgbClr val="475569"/>
                 </a:solidFill>
               </a:rPr>
-              <a:t> state machines, duplicate boundaries 99/100/101 m and 71/72/73 h, SLA, analytics; 97.9% coverage</a:t>
+              <a:t> state machines, duplicate boundaries 99/100/101 m and 71/72/73 h, SLA, schedules, ratings, SMS text; 97.9% coverage</a:t>
             </a:r>
           </a:p>
           <a:p>
@@ -4510,7 +4533,7 @@
                   <a:srgbClr val="1E293B"/>
                 </a:solidFill>
               </a:rPr>
-              <a:t>Security rules (20)</a:t>
+              <a:t>Security rules (21)</a:t>
             </a:r>
             <a:r>
               <a:rPr sz="1600">
@@ -4533,7 +4556,7 @@
                   <a:srgbClr val="1E293B"/>
                 </a:solidFill>
               </a:rPr>
-              <a:t>API integration (79)</a:t>
+              <a:t>API integration (91)</a:t>
             </a:r>
             <a:r>
               <a:rPr sz="1600">
@@ -4541,7 +4564,7 @@
                   <a:srgbClr val="475569"/>
                 </a:solidFill>
               </a:rPr>
-              <a:t> validation, authorisation, wrong-state and concurrency for every command; push with a fake sender</a:t>
+              <a:t> validation, authorisation, wrong-state and concurrency for every command; push and SMS with fake gateways</a:t>
             </a:r>
           </a:p>
           <a:p>
@@ -4556,7 +4579,7 @@
                   <a:srgbClr val="1E293B"/>
                 </a:solidFill>
               </a:rPr>
-              <a:t>End-to-end + PWA (15)</a:t>
+              <a:t>End-to-end, PWA, live site (21)</a:t>
             </a:r>
             <a:r>
               <a:rPr sz="1600">
@@ -4564,7 +4587,7 @@
                   <a:srgbClr val="475569"/>
                 </a:solidFill>
               </a:rPr>
-              <a:t> full lifecycle across 3 browsers, duplicates, Me too, alerts, access denied, Google sign-in, POPIA deletion, offline install; Chrome and Firefox</a:t>
+              <a:t> full lifecycle across 3 browsers, offline drafts, scheduled alerts, bulk assign, transparency, access denied, Google sign-in; CDN and CSP on the live site</a:t>
             </a:r>
           </a:p>
           <a:p>
@@ -4587,7 +4610,7 @@
                   <a:srgbClr val="475569"/>
                 </a:solidFill>
               </a:rPr>
-              <a:t> update reaches the resident in 2.5 s (target 5 s), screens &lt; 1.1 s, p95 command 28 ms, 0 WCAG violations</a:t>
+              <a:t> update reaches the resident in 2.5 s (target 5 s), screens &lt; 1.1 s, p95 command 28 ms, 0 WCAG and 0 CSP violations</a:t>
             </a:r>
           </a:p>
         </p:txBody>
@@ -4932,7 +4955,7 @@
                   <a:srgbClr val="475569"/>
                 </a:solidFill>
               </a:rPr>
-              <a:t> push and SMS for residents who are not in the app; a pilot with one department</a:t>
+              <a:t> a paid SMS gateway with a send queue; Cloud Scheduler for exact alert times; a pilot with one department</a:t>
             </a:r>
           </a:p>
         </p:txBody>

</xml_diff>

<commit_message>
docs: test results (185/185), rebuilt slides and report
Co-Authored-By: Claude Opus 5.5 <noreply@anthropic.com>
</commit_message>
<xml_diff>
--- a/docs/presentation/CivicLink_Presentation.pptx
+++ b/docs/presentation/CivicLink_Presentation.pptx
@@ -3497,7 +3497,7 @@
                   <a:srgbClr val="1E293B"/>
                 </a:solidFill>
               </a:rPr>
-              <a:t>Four roles, one lifecycle: all 37 requirements delivered</a:t>
+              <a:t>Four roles, one lifecycle: all 39 requirements delivered</a:t>
             </a:r>
           </a:p>
         </p:txBody>
@@ -3706,7 +3706,7 @@
                   <a:srgbClr val="1E293B"/>
                 </a:solidFill>
               </a:rPr>
-              <a:t>Transparency</a:t>
+              <a:t>Open to everyone</a:t>
             </a:r>
             <a:r>
               <a:rPr sz="1700">
@@ -3714,7 +3714,7 @@
                   <a:srgbClr val="475569"/>
                 </a:solidFill>
               </a:rPr>
-              <a:t> a public page with time-to-fix, SLA compliance and satisfaction, served from the CDN</a:t>
+              <a:t> a public home with alerts and open issues nearby; report as a guest, keep it with an account later; public time-to-fix figures from the CDN</a:t>
             </a:r>
           </a:p>
         </p:txBody>
@@ -3991,7 +3991,7 @@
                   <a:srgbClr val="475569"/>
                 </a:solidFill>
               </a:rPr>
-              <a:t> one registry of 31 commands: auth, roles, Zod validation, transactions; served by Vercel (deployed) or Cloud Functions (local)</a:t>
+              <a:t> one registry of 36 commands: auth, roles, Zod validation, transactions; served by Vercel (deployed) or Cloud Functions (local)</a:t>
             </a:r>
           </a:p>
           <a:p>
@@ -4439,7 +4439,7 @@
                   <a:srgbClr val="1E293B"/>
                 </a:solidFill>
               </a:rPr>
-              <a:t>173 automated tests, all green</a:t>
+              <a:t>185 automated tests, all green</a:t>
             </a:r>
           </a:p>
         </p:txBody>
@@ -4510,7 +4510,7 @@
                   <a:srgbClr val="1E293B"/>
                 </a:solidFill>
               </a:rPr>
-              <a:t>Unit (40)</a:t>
+              <a:t>Unit (41)</a:t>
             </a:r>
             <a:r>
               <a:rPr sz="1600">
@@ -4533,7 +4533,7 @@
                   <a:srgbClr val="1E293B"/>
                 </a:solidFill>
               </a:rPr>
-              <a:t>Security rules (21)</a:t>
+              <a:t>Security rules (22)</a:t>
             </a:r>
             <a:r>
               <a:rPr sz="1600">
@@ -4556,7 +4556,7 @@
                   <a:srgbClr val="1E293B"/>
                 </a:solidFill>
               </a:rPr>
-              <a:t>API integration (91)</a:t>
+              <a:t>API integration (99)</a:t>
             </a:r>
             <a:r>
               <a:rPr sz="1600">
@@ -4579,7 +4579,7 @@
                   <a:srgbClr val="1E293B"/>
                 </a:solidFill>
               </a:rPr>
-              <a:t>End-to-end, PWA, live site (21)</a:t>
+              <a:t>End-to-end, PWA, live site (23)</a:t>
             </a:r>
             <a:r>
               <a:rPr sz="1600">

</xml_diff>

<commit_message>
docs: final pass against rubric and template
- Report: four design decisions in full (D1-D4) plus a supporting-decisions table; ADR-0007..0009
- APA in-text citations for every reference; Twilio, MDN CSP, Firebase anonymous auth, Vercel CDN added
- Press figures checked against sources (VERIFY removed); timings and counts from the latest full run
- UI evidence grouped by journey (25 -> 15 figures; 93 -> 87 pages); guest clean-up limitation
- W1 activity/sequence and architecture diagrams show guest, offline outbox and clientId paths
- README (features, tests, stack), ADR fixes; slides with overview diagram and D1-D4; demo script

Co-Authored-By: Claude Opus 5.5 <noreply@anthropic.com>
</commit_message>
<xml_diff>
--- a/docs/presentation/CivicLink_Presentation.pptx
+++ b/docs/presentation/CivicLink_Presentation.pptx
@@ -3721,7 +3721,7 @@
       </p:sp>
       <p:pic>
         <p:nvPicPr>
-          <p:cNvPr id="7" name="Picture 6" descr="state-report.png"/>
+          <p:cNvPr id="7" name="Picture 6" descr="g1-entry.png"/>
           <p:cNvPicPr>
             <a:picLocks noChangeAspect="1"/>
           </p:cNvPicPr>
@@ -3735,8 +3735,8 @@
         </p:blipFill>
         <p:spPr>
           <a:xfrm>
-            <a:off x="7498079" y="1463040"/>
-            <a:ext cx="4297680" cy="3093661"/>
+            <a:off x="7315200" y="1645920"/>
+            <a:ext cx="4572000" cy="3370599"/>
           </a:xfrm>
           <a:prstGeom prst="rect">
             <a:avLst/>
@@ -3905,7 +3905,7 @@
       </p:sp>
       <p:pic>
         <p:nvPicPr>
-          <p:cNvPr id="6" name="Picture 5" descr="architecture.png"/>
+          <p:cNvPr id="6" name="Picture 5" descr="overview.png"/>
           <p:cNvPicPr>
             <a:picLocks noChangeAspect="1"/>
           </p:cNvPicPr>
@@ -3919,8 +3919,8 @@
         </p:blipFill>
         <p:spPr>
           <a:xfrm>
-            <a:off x="548640" y="1463040"/>
-            <a:ext cx="5903024" cy="4754880"/>
+            <a:off x="457200" y="1463040"/>
+            <a:ext cx="7132320" cy="4996543"/>
           </a:xfrm>
           <a:prstGeom prst="rect">
             <a:avLst/>
@@ -4230,7 +4230,7 @@
               </a:spcAft>
             </a:pPr>
             <a:r>
-              <a:rPr sz="1800" b="1">
+              <a:rPr sz="1600" b="1">
                 <a:solidFill>
                   <a:srgbClr val="1E293B"/>
                 </a:solidFill>
@@ -4238,7 +4238,7 @@
               <a:t>D1: Every state change is a server command in a transaction</a:t>
             </a:r>
             <a:r>
-              <a:rPr sz="1800">
+              <a:rPr sz="1600">
                 <a:solidFill>
                   <a:srgbClr val="475569"/>
                 </a:solidFill>
@@ -4253,20 +4253,20 @@
               </a:spcAft>
             </a:pPr>
             <a:r>
-              <a:rPr sz="1800" b="1">
+              <a:rPr sz="1600" b="1">
                 <a:solidFill>
                   <a:srgbClr val="1E293B"/>
                 </a:solidFill>
               </a:rPr>
-              <a:t>D3: Free-tier deployment without Cloud Functions</a:t>
-            </a:r>
-            <a:r>
-              <a:rPr sz="1800">
+              <a:t>D2: Free-tier deployment without Cloud Functions</a:t>
+            </a:r>
+            <a:r>
+              <a:rPr sz="1600">
                 <a:solidFill>
                   <a:srgbClr val="475569"/>
                 </a:solidFill>
               </a:rPr>
-              <a:t> Firebase Spark + a Node API on Vercel; photos compressed to ≤ 700 KB and stored in Firestore with real-type checks. One command registry, two adapters, and CI runs every E2E test through both.</a:t>
+              <a:t> Firebase Spark + a Node API on Vercel; photos compressed to ≤ 700 KB and stored in Firestore with real-type checks. One command registry, two adapters; CI runs every E2E test through both.</a:t>
             </a:r>
           </a:p>
           <a:p>
@@ -4276,20 +4276,20 @@
               </a:spcAft>
             </a:pPr>
             <a:r>
-              <a:rPr sz="1800" b="1">
+              <a:rPr sz="1600" b="1">
                 <a:solidFill>
                   <a:srgbClr val="1E293B"/>
                 </a:solidFill>
               </a:rPr>
-              <a:t>D5: Offline reports through an outbox and idempotent commands</a:t>
-            </a:r>
-            <a:r>
-              <a:rPr sz="1800">
+              <a:t>D3: Offline reports through an outbox and idempotent commands</a:t>
+            </a:r>
+            <a:r>
+              <a:rPr sz="1600">
                 <a:solidFill>
                   <a:srgbClr val="475569"/>
                 </a:solidFill>
               </a:rPr>
-              <a:t> Saved on the phone (IndexedDB) and sent on reconnect with a device-chosen id, so a resend is stored once. Works in every browser, unlike Background Sync.</a:t>
+              <a:t> Saved on the phone (IndexedDB), sent on reconnect with a device-chosen id, so a resend is stored once. Works in every browser, unlike Background Sync.</a:t>
             </a:r>
           </a:p>
           <a:p>
@@ -4299,20 +4299,43 @@
               </a:spcAft>
             </a:pPr>
             <a:r>
-              <a:rPr sz="1800" b="1">
+              <a:rPr sz="1600" b="1">
                 <a:solidFill>
                   <a:srgbClr val="1E293B"/>
                 </a:solidFill>
               </a:rPr>
+              <a:t>D4: Guests through anonymous sign-in, not open endpoints</a:t>
+            </a:r>
+            <a:r>
+              <a:rPr sz="1600">
+                <a:solidFill>
+                  <a:srgbClr val="475569"/>
+                </a:solidFill>
+              </a:rPr>
+              <a:t> A guest is a real authenticated user, so every rule still applies; upgrade in place by linking email or Google; 3 reports/hour per guest, 10 sessions/hour per address.</a:t>
+            </a:r>
+          </a:p>
+          <a:p>
+            <a:pPr>
+              <a:spcAft>
+                <a:spcPts val="1000"/>
+              </a:spcAft>
+            </a:pPr>
+            <a:r>
+              <a:rPr sz="1600" b="1">
+                <a:solidFill>
+                  <a:srgbClr val="1E293B"/>
+                </a:solidFill>
+              </a:rPr>
               <a:t>Also:</a:t>
             </a:r>
             <a:r>
-              <a:rPr sz="1800">
+              <a:rPr sz="1600">
                 <a:solidFill>
                   <a:srgbClr val="475569"/>
                 </a:solidFill>
               </a:rPr>
-              <a:t> public figures from the CDN cache (D6); enforced CSP + HSTS; Leaflet + OpenStreetMap instead of Google Maps; React SPA instead of Next.js.</a:t>
+              <a:t> public data from the CDN cache; enforced CSP + HSTS; Leaflet + OpenStreetMap; React SPA instead of Next.js.</a:t>
             </a:r>
           </a:p>
         </p:txBody>
@@ -4610,7 +4633,7 @@
                   <a:srgbClr val="475569"/>
                 </a:solidFill>
               </a:rPr>
-              <a:t> update reaches the resident in 2.5 s (target 5 s), screens &lt; 1.1 s, p95 command 28 ms, 0 WCAG and 0 CSP violations</a:t>
+              <a:t> update reaches the resident in 1.9 s (target 5 s), screens &lt; 1.4 s, p95 command 73 ms, 0 WCAG and 0 CSP violations</a:t>
             </a:r>
           </a:p>
         </p:txBody>
@@ -4840,7 +4863,7 @@
                   <a:srgbClr val="475569"/>
                 </a:solidFill>
               </a:rPr>
-              <a:t> E2E-01 passes in Chromium and Firefox</a:t>
+              <a:t> E2E-01 passes in Chromium and Firefox, locally and on the live site</a:t>
             </a:r>
           </a:p>
           <a:p>
@@ -4886,7 +4909,7 @@
                   <a:srgbClr val="475569"/>
                 </a:solidFill>
               </a:rPr>
-              <a:t> 20 rule tests + authorisation tests + E2E-04</a:t>
+              <a:t> 22 rule tests + authorisation tests + E2E-04</a:t>
             </a:r>
           </a:p>
           <a:p>
@@ -4909,7 +4932,7 @@
                   <a:srgbClr val="475569"/>
                 </a:solidFill>
               </a:rPr>
-              <a:t> 0.09 s to the official, 2.47 s to the resident</a:t>
+              <a:t> 0.07 s to the official, 1.9 s to the resident</a:t>
             </a:r>
           </a:p>
           <a:p>

</xml_diff>